<commit_message>
World-class README + hero banner + CI + MIT license; refresh deck with links/result
- README.md: centered hero (assets/hero.svg), badge rows (live app / dashboard / deck / CI /
  license / zero-training), diagram, real numbers table, verifier-vs-judge table, quickstart, layout.
- assets/hero.svg: branded hero banner (rising accuracy curve, key stats).
- .github/workflows/ci.yml: runs check.sh on push/PR → real CI status badge.
- LICENSE: MIT.
- Lifeline_Deck.pptx: title + demo + close slides now carry the live app/dashboard links and the
  12/12-dangerous-caught / 0-leaks result.

Co-Authored-By: Claude Opus 4.8 <noreply@anthropic.com>
</commit_message>
<xml_diff>
--- a/Lifeline_Deck.pptx
+++ b/Lifeline_Deck.pptx
@@ -4229,7 +4229,7 @@
                   <a:srgbClr val="5C9DFF"/>
                 </a:solidFill>
               </a:rPr>
-              <a:t>Build the machine + Build the future  ·  Inference-Time Compute Hackathon 2026  ·  github.com/vnmoorthy/lifeline</a:t>
+              <a:t>Build the machine  ·  Live app: vnmoorthy.github.io/lifeline  ·  github.com/vnmoorthy/lifeline</a:t>
             </a:r>
           </a:p>
         </p:txBody>
@@ -5818,7 +5818,7 @@
                   <a:srgbClr val="EEF3F9"/>
                 </a:solidFill>
               </a:rPr>
-              <a:t>•  Live site: the accuracy-vs-compute dashboard + the verifier-vs-judge result.</a:t>
+              <a:t>•  Live: vnmoorthy.github.io/lifeline (talkable voice app) + /dashboard.html (curves + verifier-vs-judge).</a:t>
             </a:r>
           </a:p>
         </p:txBody>
@@ -6224,7 +6224,7 @@
                   <a:srgbClr val="EEF3F9"/>
                 </a:solidFill>
               </a:rPr>
-              <a:t>•  0 unsafe leaks on the adversarial set — fluent-but-wrong gets rejected, every time.</a:t>
+              <a:t>•  0 unsafe leaks on the 42-candidate adversarial set — 12/12 fluent-but-dangerous answers rejected.</a:t>
             </a:r>
           </a:p>
           <a:p>
@@ -6239,7 +6239,7 @@
                   <a:srgbClr val="EEF3F9"/>
                 </a:solidFill>
               </a:rPr>
-              <a:t>•  Code, dashboard, and demo: github.com/vnmoorthy/lifeline</a:t>
+              <a:t>•  Live app: vnmoorthy.github.io/lifeline   ·   Dashboard: vnmoorthy.github.io/lifeline/dashboard.html</a:t>
             </a:r>
           </a:p>
           <a:p>
@@ -6254,7 +6254,7 @@
                   <a:srgbClr val="EEF3F9"/>
                 </a:solidFill>
               </a:rPr>
-              <a:t>•  Build as if compute is free — then verify.</a:t>
+              <a:t>•  Code: github.com/vnmoorthy/lifeline   ·   Build as if compute is free, then verify.</a:t>
             </a:r>
           </a:p>
         </p:txBody>

</xml_diff>